<commit_message>
updated week 8 with deque operations example
</commit_message>
<xml_diff>
--- a/Week8/Week8_Slides.pptx
+++ b/Week8/Week8_Slides.pptx
@@ -15,10 +15,11 @@
     <p:sldId id="275" r:id="rId9"/>
     <p:sldId id="276" r:id="rId10"/>
     <p:sldId id="277" r:id="rId11"/>
-    <p:sldId id="278" r:id="rId12"/>
-    <p:sldId id="279" r:id="rId13"/>
-    <p:sldId id="280" r:id="rId14"/>
-    <p:sldId id="269" r:id="rId15"/>
+    <p:sldId id="281" r:id="rId12"/>
+    <p:sldId id="278" r:id="rId13"/>
+    <p:sldId id="279" r:id="rId14"/>
+    <p:sldId id="280" r:id="rId15"/>
+    <p:sldId id="269" r:id="rId16"/>
   </p:sldIdLst>
   <p:sldSz cx="12192000" cy="6858000"/>
   <p:notesSz cx="6858000" cy="9144000"/>
@@ -311,7 +312,7 @@
           <a:p>
             <a:fld id="{8322A558-B964-4799-A94A-632D1601F177}" type="datetimeFigureOut">
               <a:rPr lang="en-IN" smtClean="0"/>
-              <a:t>17-07-2025</a:t>
+              <a:t>29-07-2025</a:t>
             </a:fld>
             <a:endParaRPr lang="en-IN"/>
           </a:p>
@@ -586,7 +587,7 @@
           <a:p>
             <a:fld id="{8322A558-B964-4799-A94A-632D1601F177}" type="datetimeFigureOut">
               <a:rPr lang="en-IN" smtClean="0"/>
-              <a:t>17-07-2025</a:t>
+              <a:t>29-07-2025</a:t>
             </a:fld>
             <a:endParaRPr lang="en-IN"/>
           </a:p>
@@ -780,7 +781,7 @@
           <a:p>
             <a:fld id="{8322A558-B964-4799-A94A-632D1601F177}" type="datetimeFigureOut">
               <a:rPr lang="en-IN" smtClean="0"/>
-              <a:t>17-07-2025</a:t>
+              <a:t>29-07-2025</a:t>
             </a:fld>
             <a:endParaRPr lang="en-IN"/>
           </a:p>
@@ -1053,7 +1054,7 @@
           <a:p>
             <a:fld id="{8322A558-B964-4799-A94A-632D1601F177}" type="datetimeFigureOut">
               <a:rPr lang="en-IN" smtClean="0"/>
-              <a:t>17-07-2025</a:t>
+              <a:t>29-07-2025</a:t>
             </a:fld>
             <a:endParaRPr lang="en-IN"/>
           </a:p>
@@ -1394,7 +1395,7 @@
           <a:p>
             <a:fld id="{8322A558-B964-4799-A94A-632D1601F177}" type="datetimeFigureOut">
               <a:rPr lang="en-IN" smtClean="0"/>
-              <a:t>17-07-2025</a:t>
+              <a:t>29-07-2025</a:t>
             </a:fld>
             <a:endParaRPr lang="en-IN"/>
           </a:p>
@@ -2017,7 +2018,7 @@
           <a:p>
             <a:fld id="{8322A558-B964-4799-A94A-632D1601F177}" type="datetimeFigureOut">
               <a:rPr lang="en-IN" smtClean="0"/>
-              <a:t>17-07-2025</a:t>
+              <a:t>29-07-2025</a:t>
             </a:fld>
             <a:endParaRPr lang="en-IN"/>
           </a:p>
@@ -2877,7 +2878,7 @@
           <a:p>
             <a:fld id="{8322A558-B964-4799-A94A-632D1601F177}" type="datetimeFigureOut">
               <a:rPr lang="en-IN" smtClean="0"/>
-              <a:t>17-07-2025</a:t>
+              <a:t>29-07-2025</a:t>
             </a:fld>
             <a:endParaRPr lang="en-IN"/>
           </a:p>
@@ -3047,7 +3048,7 @@
           <a:p>
             <a:fld id="{8322A558-B964-4799-A94A-632D1601F177}" type="datetimeFigureOut">
               <a:rPr lang="en-IN" smtClean="0"/>
-              <a:t>17-07-2025</a:t>
+              <a:t>29-07-2025</a:t>
             </a:fld>
             <a:endParaRPr lang="en-IN"/>
           </a:p>
@@ -3227,7 +3228,7 @@
           <a:p>
             <a:fld id="{8322A558-B964-4799-A94A-632D1601F177}" type="datetimeFigureOut">
               <a:rPr lang="en-IN" smtClean="0"/>
-              <a:t>17-07-2025</a:t>
+              <a:t>29-07-2025</a:t>
             </a:fld>
             <a:endParaRPr lang="en-IN"/>
           </a:p>
@@ -3397,7 +3398,7 @@
           <a:p>
             <a:fld id="{8322A558-B964-4799-A94A-632D1601F177}" type="datetimeFigureOut">
               <a:rPr lang="en-IN" smtClean="0"/>
-              <a:t>17-07-2025</a:t>
+              <a:t>29-07-2025</a:t>
             </a:fld>
             <a:endParaRPr lang="en-IN"/>
           </a:p>
@@ -3644,7 +3645,7 @@
           <a:p>
             <a:fld id="{8322A558-B964-4799-A94A-632D1601F177}" type="datetimeFigureOut">
               <a:rPr lang="en-IN" smtClean="0"/>
-              <a:t>17-07-2025</a:t>
+              <a:t>29-07-2025</a:t>
             </a:fld>
             <a:endParaRPr lang="en-IN"/>
           </a:p>
@@ -3936,7 +3937,7 @@
           <a:p>
             <a:fld id="{8322A558-B964-4799-A94A-632D1601F177}" type="datetimeFigureOut">
               <a:rPr lang="en-IN" smtClean="0"/>
-              <a:t>17-07-2025</a:t>
+              <a:t>29-07-2025</a:t>
             </a:fld>
             <a:endParaRPr lang="en-IN"/>
           </a:p>
@@ -4380,7 +4381,7 @@
           <a:p>
             <a:fld id="{8322A558-B964-4799-A94A-632D1601F177}" type="datetimeFigureOut">
               <a:rPr lang="en-IN" smtClean="0"/>
-              <a:t>17-07-2025</a:t>
+              <a:t>29-07-2025</a:t>
             </a:fld>
             <a:endParaRPr lang="en-IN"/>
           </a:p>
@@ -4498,7 +4499,7 @@
           <a:p>
             <a:fld id="{8322A558-B964-4799-A94A-632D1601F177}" type="datetimeFigureOut">
               <a:rPr lang="en-IN" smtClean="0"/>
-              <a:t>17-07-2025</a:t>
+              <a:t>29-07-2025</a:t>
             </a:fld>
             <a:endParaRPr lang="en-IN"/>
           </a:p>
@@ -4593,7 +4594,7 @@
           <a:p>
             <a:fld id="{8322A558-B964-4799-A94A-632D1601F177}" type="datetimeFigureOut">
               <a:rPr lang="en-IN" smtClean="0"/>
-              <a:t>17-07-2025</a:t>
+              <a:t>29-07-2025</a:t>
             </a:fld>
             <a:endParaRPr lang="en-IN"/>
           </a:p>
@@ -4872,7 +4873,7 @@
           <a:p>
             <a:fld id="{8322A558-B964-4799-A94A-632D1601F177}" type="datetimeFigureOut">
               <a:rPr lang="en-IN" smtClean="0"/>
-              <a:t>17-07-2025</a:t>
+              <a:t>29-07-2025</a:t>
             </a:fld>
             <a:endParaRPr lang="en-IN"/>
           </a:p>
@@ -5147,7 +5148,7 @@
           <a:p>
             <a:fld id="{8322A558-B964-4799-A94A-632D1601F177}" type="datetimeFigureOut">
               <a:rPr lang="en-IN" smtClean="0"/>
-              <a:t>17-07-2025</a:t>
+              <a:t>29-07-2025</a:t>
             </a:fld>
             <a:endParaRPr lang="en-IN"/>
           </a:p>
@@ -5576,7 +5577,7 @@
           <a:p>
             <a:fld id="{8322A558-B964-4799-A94A-632D1601F177}" type="datetimeFigureOut">
               <a:rPr lang="en-IN" smtClean="0"/>
-              <a:t>17-07-2025</a:t>
+              <a:t>29-07-2025</a:t>
             </a:fld>
             <a:endParaRPr lang="en-IN"/>
           </a:p>
@@ -6366,7 +6367,7 @@
           <p:cNvPr id="2" name="Title 1">
             <a:extLst>
               <a:ext uri="{FF2B5EF4-FFF2-40B4-BE49-F238E27FC236}">
-                <a16:creationId xmlns:a16="http://schemas.microsoft.com/office/drawing/2014/main" id="{17F1B092-CF2C-A7A9-701F-9F5E2E7E2FC5}"/>
+                <a16:creationId xmlns:a16="http://schemas.microsoft.com/office/drawing/2014/main" id="{C1CDA465-4CD5-FBA1-6A26-7CDE0261F6FF}"/>
               </a:ext>
             </a:extLst>
           </p:cNvPr>
@@ -6384,7 +6385,7 @@
           <a:p>
             <a:r>
               <a:rPr lang="en-IN" b="1" dirty="0"/>
-              <a:t>ADT Specifications</a:t>
+              <a:t>Deque – Example Operations</a:t>
             </a:r>
           </a:p>
         </p:txBody>
@@ -6394,7 +6395,7 @@
           <p:cNvPr id="3" name="Content Placeholder 2">
             <a:extLst>
               <a:ext uri="{FF2B5EF4-FFF2-40B4-BE49-F238E27FC236}">
-                <a16:creationId xmlns:a16="http://schemas.microsoft.com/office/drawing/2014/main" id="{D0E934D7-7E31-4A3C-7E9C-B4B81DC3E4C7}"/>
+                <a16:creationId xmlns:a16="http://schemas.microsoft.com/office/drawing/2014/main" id="{86F8BE6A-EDBE-269F-FDE2-A4AE7D474B39}"/>
               </a:ext>
             </a:extLst>
           </p:cNvPr>
@@ -6411,63 +6412,91 @@
           <a:lstStyle/>
           <a:p>
             <a:r>
-              <a:rPr lang="en-US" dirty="0"/>
-              <a:t>All three structures are linear collections but differ in access restrictions:</a:t>
+              <a:rPr lang="en-IN" dirty="0"/>
+              <a:t>Imagine a deque D that is initially empty:</a:t>
             </a:r>
           </a:p>
           <a:p>
             <a:pPr lvl="1"/>
             <a:r>
-              <a:rPr lang="en-US" dirty="0"/>
-              <a:t>Stack: Single end (top) only.</a:t>
+              <a:rPr lang="en-IN" dirty="0" err="1"/>
+              <a:t>D.addRear</a:t>
+            </a:r>
+            <a:r>
+              <a:rPr lang="en-IN" dirty="0"/>
+              <a:t>(‘A’)</a:t>
+            </a:r>
+          </a:p>
+          <a:p>
+            <a:pPr lvl="2"/>
+            <a:r>
+              <a:rPr lang="en-IN" dirty="0"/>
+              <a:t>Deque: [‘A’]</a:t>
             </a:r>
           </a:p>
           <a:p>
             <a:pPr lvl="1"/>
             <a:r>
-              <a:rPr lang="en-US" dirty="0"/>
-              <a:t>Queue: Two ends with fixed roles.</a:t>
+              <a:rPr lang="en-IN" dirty="0" err="1"/>
+              <a:t>D.addFront</a:t>
+            </a:r>
+            <a:r>
+              <a:rPr lang="en-IN" dirty="0"/>
+              <a:t>(‘B’)</a:t>
+            </a:r>
+          </a:p>
+          <a:p>
+            <a:pPr lvl="2"/>
+            <a:r>
+              <a:rPr lang="en-IN" dirty="0"/>
+              <a:t>Deque: [‘B’, ‘A’]</a:t>
             </a:r>
           </a:p>
           <a:p>
             <a:pPr lvl="1"/>
             <a:r>
-              <a:rPr lang="en-US" dirty="0"/>
-              <a:t>Deque: Two ends with symmetric roles.</a:t>
-            </a:r>
-          </a:p>
-          <a:p>
+              <a:rPr lang="en-IN" dirty="0" err="1"/>
+              <a:t>D.addRear</a:t>
+            </a:r>
             <a:r>
               <a:rPr lang="en-IN" dirty="0"/>
-              <a:t>ADT specification includes:</a:t>
+              <a:t>(‘C’)</a:t>
+            </a:r>
+          </a:p>
+          <a:p>
+            <a:pPr lvl="2"/>
+            <a:r>
+              <a:rPr lang="en-IN" dirty="0"/>
+              <a:t>Deque: ['B', 'A', 'C']</a:t>
             </a:r>
           </a:p>
           <a:p>
             <a:pPr lvl="1"/>
             <a:r>
+              <a:rPr lang="en-IN" dirty="0" err="1"/>
+              <a:t>D.peekFront</a:t>
+            </a:r>
+            <a:r>
               <a:rPr lang="en-IN" dirty="0"/>
-              <a:t>Clearly defined operation signatures.</a:t>
-            </a:r>
-          </a:p>
-          <a:p>
-            <a:pPr lvl="1"/>
+              <a:t>()</a:t>
+            </a:r>
+          </a:p>
+          <a:p>
+            <a:pPr lvl="2"/>
             <a:r>
               <a:rPr lang="en-IN" dirty="0"/>
-              <a:t>Preconditions (should be non-empty for pop, dequeue)</a:t>
-            </a:r>
-          </a:p>
-          <a:p>
-            <a:pPr lvl="1"/>
+              <a:t>Returns: ‘B’</a:t>
+            </a:r>
+          </a:p>
+          <a:p>
+            <a:pPr lvl="2"/>
             <a:r>
               <a:rPr lang="en-IN" dirty="0"/>
-              <a:t>Postconditions describing state transitions.</a:t>
-            </a:r>
-          </a:p>
-          <a:p>
-            <a:pPr lvl="1"/>
-            <a:r>
-              <a:rPr lang="en-US" dirty="0"/>
-              <a:t>Behavioral invariants guaranteeing predictable behavior.</a:t>
+              <a:t>Deque: ['B', 'A', 'C’] (</a:t>
+            </a:r>
+            <a:r>
+              <a:rPr lang="en-IN"/>
+              <a:t>no change)</a:t>
             </a:r>
             <a:endParaRPr lang="en-IN" dirty="0"/>
           </a:p>
@@ -6476,7 +6505,7 @@
     </p:spTree>
     <p:extLst>
       <p:ext uri="{BB962C8B-B14F-4D97-AF65-F5344CB8AC3E}">
-        <p14:creationId xmlns:p14="http://schemas.microsoft.com/office/powerpoint/2010/main" val="1755662860"/>
+        <p14:creationId xmlns:p14="http://schemas.microsoft.com/office/powerpoint/2010/main" val="1586297023"/>
       </p:ext>
     </p:extLst>
   </p:cSld>
@@ -6508,7 +6537,7 @@
           <p:cNvPr id="2" name="Title 1">
             <a:extLst>
               <a:ext uri="{FF2B5EF4-FFF2-40B4-BE49-F238E27FC236}">
-                <a16:creationId xmlns:a16="http://schemas.microsoft.com/office/drawing/2014/main" id="{6BB182C6-225B-ECDD-FD2E-DE18528F705C}"/>
+                <a16:creationId xmlns:a16="http://schemas.microsoft.com/office/drawing/2014/main" id="{17F1B092-CF2C-A7A9-701F-9F5E2E7E2FC5}"/>
               </a:ext>
             </a:extLst>
           </p:cNvPr>
@@ -6526,7 +6555,7 @@
           <a:p>
             <a:r>
               <a:rPr lang="en-IN" b="1" dirty="0"/>
-              <a:t>Complexity Analysis</a:t>
+              <a:t>ADT Specifications</a:t>
             </a:r>
           </a:p>
         </p:txBody>
@@ -6536,7 +6565,7 @@
           <p:cNvPr id="3" name="Content Placeholder 2">
             <a:extLst>
               <a:ext uri="{FF2B5EF4-FFF2-40B4-BE49-F238E27FC236}">
-                <a16:creationId xmlns:a16="http://schemas.microsoft.com/office/drawing/2014/main" id="{AC54A34A-5C91-A789-F1AC-76EE8B1A5B17}"/>
+                <a16:creationId xmlns:a16="http://schemas.microsoft.com/office/drawing/2014/main" id="{D0E934D7-7E31-4A3C-7E9C-B4B81DC3E4C7}"/>
               </a:ext>
             </a:extLst>
           </p:cNvPr>
@@ -6554,109 +6583,62 @@
           <a:p>
             <a:r>
               <a:rPr lang="en-US" dirty="0"/>
-              <a:t>Idealized cost model assumes optimal backing store (array with circular indexing, doubly linked list, etc.).</a:t>
-            </a:r>
-          </a:p>
-          <a:p>
+              <a:t>All three structures are linear collections but differ in access restrictions:</a:t>
+            </a:r>
+          </a:p>
+          <a:p>
+            <a:pPr lvl="1"/>
             <a:r>
               <a:rPr lang="en-US" dirty="0"/>
-              <a:t>Stack: push, pop, top, </a:t>
-            </a:r>
-            <a:r>
-              <a:rPr lang="en-US" dirty="0" err="1"/>
-              <a:t>isEmpty</a:t>
-            </a:r>
+              <a:t>Stack: Single end (top) only.</a:t>
+            </a:r>
+          </a:p>
+          <a:p>
+            <a:pPr lvl="1"/>
             <a:r>
               <a:rPr lang="en-US" dirty="0"/>
-              <a:t>, size - O(1) time complexity.</a:t>
-            </a:r>
-          </a:p>
-          <a:p>
+              <a:t>Queue: Two ends with fixed roles.</a:t>
+            </a:r>
+          </a:p>
+          <a:p>
+            <a:pPr lvl="1"/>
             <a:r>
               <a:rPr lang="en-US" dirty="0"/>
-              <a:t>Queue: enqueue, dequeue, front, </a:t>
-            </a:r>
-            <a:r>
-              <a:rPr lang="en-US" dirty="0" err="1"/>
-              <a:t>isEmpty</a:t>
-            </a:r>
+              <a:t>Deque: Two ends with symmetric roles.</a:t>
+            </a:r>
+          </a:p>
+          <a:p>
+            <a:r>
+              <a:rPr lang="en-IN" dirty="0"/>
+              <a:t>ADT specification includes:</a:t>
+            </a:r>
+          </a:p>
+          <a:p>
+            <a:pPr lvl="1"/>
+            <a:r>
+              <a:rPr lang="en-IN" dirty="0"/>
+              <a:t>Clearly defined operation signatures.</a:t>
+            </a:r>
+          </a:p>
+          <a:p>
+            <a:pPr lvl="1"/>
+            <a:r>
+              <a:rPr lang="en-IN" dirty="0"/>
+              <a:t>Preconditions (should be non-empty for pop, dequeue)</a:t>
+            </a:r>
+          </a:p>
+          <a:p>
+            <a:pPr lvl="1"/>
+            <a:r>
+              <a:rPr lang="en-IN" dirty="0"/>
+              <a:t>Postconditions describing state transitions.</a:t>
+            </a:r>
+          </a:p>
+          <a:p>
+            <a:pPr lvl="1"/>
             <a:r>
               <a:rPr lang="en-US" dirty="0"/>
-              <a:t>, size - O(1).</a:t>
-            </a:r>
-          </a:p>
-          <a:p>
-            <a:r>
-              <a:rPr lang="en-US" dirty="0"/>
-              <a:t>Deque: </a:t>
-            </a:r>
-            <a:r>
-              <a:rPr lang="en-US" dirty="0" err="1"/>
-              <a:t>addFront</a:t>
-            </a:r>
-            <a:r>
-              <a:rPr lang="en-US" dirty="0"/>
-              <a:t>, </a:t>
-            </a:r>
-            <a:r>
-              <a:rPr lang="en-US" dirty="0" err="1"/>
-              <a:t>addRear</a:t>
-            </a:r>
-            <a:r>
-              <a:rPr lang="en-US" dirty="0"/>
-              <a:t>, </a:t>
-            </a:r>
-            <a:r>
-              <a:rPr lang="en-US" dirty="0" err="1"/>
-              <a:t>removeFront</a:t>
-            </a:r>
-            <a:r>
-              <a:rPr lang="en-US" dirty="0"/>
-              <a:t>, </a:t>
-            </a:r>
-            <a:r>
-              <a:rPr lang="en-US" dirty="0" err="1"/>
-              <a:t>removeRear</a:t>
-            </a:r>
-            <a:r>
-              <a:rPr lang="en-US" dirty="0"/>
-              <a:t>, </a:t>
-            </a:r>
-            <a:r>
-              <a:rPr lang="en-US" dirty="0" err="1"/>
-              <a:t>peekFront</a:t>
-            </a:r>
-            <a:r>
-              <a:rPr lang="en-US" dirty="0"/>
-              <a:t>, </a:t>
-            </a:r>
-            <a:r>
-              <a:rPr lang="en-US" dirty="0" err="1"/>
-              <a:t>peekRear</a:t>
-            </a:r>
-            <a:r>
-              <a:rPr lang="en-US" dirty="0"/>
-              <a:t>, </a:t>
-            </a:r>
-            <a:r>
-              <a:rPr lang="en-US" dirty="0" err="1"/>
-              <a:t>isEmpty</a:t>
-            </a:r>
-            <a:r>
-              <a:rPr lang="en-US" dirty="0"/>
-              <a:t>, size - O(1).</a:t>
-            </a:r>
-          </a:p>
-          <a:p>
-            <a:r>
-              <a:rPr lang="en-US" dirty="0"/>
-              <a:t>No internal shifting in properly designed structures. Complexity invariance under ADT abstraction allows reliable performance analysis independent of platform or language.</a:t>
-            </a:r>
-          </a:p>
-          <a:p>
-            <a:r>
-              <a:rPr lang="en-US" dirty="0"/>
-              <a:t>Deeper amortized analyses deferred to reading assignments.</a:t>
+              <a:t>Behavioral invariants guaranteeing predictable behavior.</a:t>
             </a:r>
             <a:endParaRPr lang="en-IN" dirty="0"/>
           </a:p>
@@ -6665,7 +6647,7 @@
     </p:spTree>
     <p:extLst>
       <p:ext uri="{BB962C8B-B14F-4D97-AF65-F5344CB8AC3E}">
-        <p14:creationId xmlns:p14="http://schemas.microsoft.com/office/powerpoint/2010/main" val="1125700860"/>
+        <p14:creationId xmlns:p14="http://schemas.microsoft.com/office/powerpoint/2010/main" val="1755662860"/>
       </p:ext>
     </p:extLst>
   </p:cSld>
@@ -6697,6 +6679,195 @@
           <p:cNvPr id="2" name="Title 1">
             <a:extLst>
               <a:ext uri="{FF2B5EF4-FFF2-40B4-BE49-F238E27FC236}">
+                <a16:creationId xmlns:a16="http://schemas.microsoft.com/office/drawing/2014/main" id="{6BB182C6-225B-ECDD-FD2E-DE18528F705C}"/>
+              </a:ext>
+            </a:extLst>
+          </p:cNvPr>
+          <p:cNvSpPr>
+            <a:spLocks noGrp="1"/>
+          </p:cNvSpPr>
+          <p:nvPr>
+            <p:ph type="title"/>
+          </p:nvPr>
+        </p:nvSpPr>
+        <p:spPr/>
+        <p:txBody>
+          <a:bodyPr/>
+          <a:lstStyle/>
+          <a:p>
+            <a:r>
+              <a:rPr lang="en-IN" b="1" dirty="0"/>
+              <a:t>Complexity Analysis</a:t>
+            </a:r>
+          </a:p>
+        </p:txBody>
+      </p:sp>
+      <p:sp>
+        <p:nvSpPr>
+          <p:cNvPr id="3" name="Content Placeholder 2">
+            <a:extLst>
+              <a:ext uri="{FF2B5EF4-FFF2-40B4-BE49-F238E27FC236}">
+                <a16:creationId xmlns:a16="http://schemas.microsoft.com/office/drawing/2014/main" id="{AC54A34A-5C91-A789-F1AC-76EE8B1A5B17}"/>
+              </a:ext>
+            </a:extLst>
+          </p:cNvPr>
+          <p:cNvSpPr>
+            <a:spLocks noGrp="1"/>
+          </p:cNvSpPr>
+          <p:nvPr>
+            <p:ph idx="1"/>
+          </p:nvPr>
+        </p:nvSpPr>
+        <p:spPr/>
+        <p:txBody>
+          <a:bodyPr/>
+          <a:lstStyle/>
+          <a:p>
+            <a:r>
+              <a:rPr lang="en-US" dirty="0"/>
+              <a:t>Idealized cost model assumes optimal backing store (array with circular indexing, doubly linked list, etc.).</a:t>
+            </a:r>
+          </a:p>
+          <a:p>
+            <a:r>
+              <a:rPr lang="en-US" dirty="0"/>
+              <a:t>Stack: push, pop, top, </a:t>
+            </a:r>
+            <a:r>
+              <a:rPr lang="en-US" dirty="0" err="1"/>
+              <a:t>isEmpty</a:t>
+            </a:r>
+            <a:r>
+              <a:rPr lang="en-US" dirty="0"/>
+              <a:t>, size - O(1) time complexity.</a:t>
+            </a:r>
+          </a:p>
+          <a:p>
+            <a:r>
+              <a:rPr lang="en-US" dirty="0"/>
+              <a:t>Queue: enqueue, dequeue, front, </a:t>
+            </a:r>
+            <a:r>
+              <a:rPr lang="en-US" dirty="0" err="1"/>
+              <a:t>isEmpty</a:t>
+            </a:r>
+            <a:r>
+              <a:rPr lang="en-US" dirty="0"/>
+              <a:t>, size - O(1).</a:t>
+            </a:r>
+          </a:p>
+          <a:p>
+            <a:r>
+              <a:rPr lang="en-US" dirty="0"/>
+              <a:t>Deque: </a:t>
+            </a:r>
+            <a:r>
+              <a:rPr lang="en-US" dirty="0" err="1"/>
+              <a:t>addFront</a:t>
+            </a:r>
+            <a:r>
+              <a:rPr lang="en-US" dirty="0"/>
+              <a:t>, </a:t>
+            </a:r>
+            <a:r>
+              <a:rPr lang="en-US" dirty="0" err="1"/>
+              <a:t>addRear</a:t>
+            </a:r>
+            <a:r>
+              <a:rPr lang="en-US" dirty="0"/>
+              <a:t>, </a:t>
+            </a:r>
+            <a:r>
+              <a:rPr lang="en-US" dirty="0" err="1"/>
+              <a:t>removeFront</a:t>
+            </a:r>
+            <a:r>
+              <a:rPr lang="en-US" dirty="0"/>
+              <a:t>, </a:t>
+            </a:r>
+            <a:r>
+              <a:rPr lang="en-US" dirty="0" err="1"/>
+              <a:t>removeRear</a:t>
+            </a:r>
+            <a:r>
+              <a:rPr lang="en-US" dirty="0"/>
+              <a:t>, </a:t>
+            </a:r>
+            <a:r>
+              <a:rPr lang="en-US" dirty="0" err="1"/>
+              <a:t>peekFront</a:t>
+            </a:r>
+            <a:r>
+              <a:rPr lang="en-US" dirty="0"/>
+              <a:t>, </a:t>
+            </a:r>
+            <a:r>
+              <a:rPr lang="en-US" dirty="0" err="1"/>
+              <a:t>peekRear</a:t>
+            </a:r>
+            <a:r>
+              <a:rPr lang="en-US" dirty="0"/>
+              <a:t>, </a:t>
+            </a:r>
+            <a:r>
+              <a:rPr lang="en-US" dirty="0" err="1"/>
+              <a:t>isEmpty</a:t>
+            </a:r>
+            <a:r>
+              <a:rPr lang="en-US" dirty="0"/>
+              <a:t>, size - O(1).</a:t>
+            </a:r>
+          </a:p>
+          <a:p>
+            <a:r>
+              <a:rPr lang="en-US" dirty="0"/>
+              <a:t>No internal shifting in properly designed structures. Complexity invariance under ADT abstraction allows reliable performance analysis independent of platform or language.</a:t>
+            </a:r>
+          </a:p>
+          <a:p>
+            <a:r>
+              <a:rPr lang="en-US" dirty="0"/>
+              <a:t>Deeper amortized analyses deferred to reading assignments.</a:t>
+            </a:r>
+            <a:endParaRPr lang="en-IN" dirty="0"/>
+          </a:p>
+        </p:txBody>
+      </p:sp>
+    </p:spTree>
+    <p:extLst>
+      <p:ext uri="{BB962C8B-B14F-4D97-AF65-F5344CB8AC3E}">
+        <p14:creationId xmlns:p14="http://schemas.microsoft.com/office/powerpoint/2010/main" val="1125700860"/>
+      </p:ext>
+    </p:extLst>
+  </p:cSld>
+  <p:clrMapOvr>
+    <a:masterClrMapping/>
+  </p:clrMapOvr>
+</p:sld>
+</file>
+
+<file path=ppt/slides/slide14.xml><?xml version="1.0" encoding="utf-8"?>
+<p:sld xmlns:a="http://schemas.openxmlformats.org/drawingml/2006/main" xmlns:r="http://schemas.openxmlformats.org/officeDocument/2006/relationships" xmlns:p="http://schemas.openxmlformats.org/presentationml/2006/main">
+  <p:cSld>
+    <p:spTree>
+      <p:nvGrpSpPr>
+        <p:cNvPr id="1" name=""/>
+        <p:cNvGrpSpPr/>
+        <p:nvPr/>
+      </p:nvGrpSpPr>
+      <p:grpSpPr>
+        <a:xfrm>
+          <a:off x="0" y="0"/>
+          <a:ext cx="0" cy="0"/>
+          <a:chOff x="0" y="0"/>
+          <a:chExt cx="0" cy="0"/>
+        </a:xfrm>
+      </p:grpSpPr>
+      <p:sp>
+        <p:nvSpPr>
+          <p:cNvPr id="2" name="Title 1">
+            <a:extLst>
+              <a:ext uri="{FF2B5EF4-FFF2-40B4-BE49-F238E27FC236}">
                 <a16:creationId xmlns:a16="http://schemas.microsoft.com/office/drawing/2014/main" id="{34185823-4C22-E4F9-7BEF-E3FFDE2DB4A6}"/>
               </a:ext>
             </a:extLst>
@@ -6817,7 +6988,7 @@
 </p:sld>
 </file>
 
-<file path=ppt/slides/slide14.xml><?xml version="1.0" encoding="utf-8"?>
+<file path=ppt/slides/slide15.xml><?xml version="1.0" encoding="utf-8"?>
 <p:sld xmlns:a="http://schemas.openxmlformats.org/drawingml/2006/main" xmlns:r="http://schemas.openxmlformats.org/officeDocument/2006/relationships" xmlns:p="http://schemas.openxmlformats.org/presentationml/2006/main">
   <p:cSld>
     <p:spTree>

</xml_diff>